<commit_message>
Add Challenges Faced section to PDF and PPTX solution docs
</commit_message>
<xml_diff>
--- a/LearnPath_Solution.pptx
+++ b/LearnPath_Solution.pptx
@@ -24,6 +24,7 @@
     <p:sldId id="272" r:id="rId23"/>
     <p:sldId id="273" r:id="rId24"/>
     <p:sldId id="274" r:id="rId25"/>
+    <p:sldId id="275" r:id="rId26"/>
   </p:sldIdLst>
   <p:sldSz cx="12191695" cy="6858000" type="screen4x3"/>
   <p:notesSz cx="6858000" cy="9144000"/>
@@ -9160,7 +9161,7 @@
                 </a:solidFill>
                 <a:latin typeface="Calibri"/>
               </a:rPr>
-              <a:t>DEPLOYMENT</a:t>
+              <a:t>ENGINEERING</a:t>
             </a:r>
           </a:p>
         </p:txBody>
@@ -9195,7 +9196,7 @@
                 </a:solidFill>
                 <a:latin typeface="Calibri"/>
               </a:rPr>
-              <a:t>Deployment &amp; Deliverables</a:t>
+              <a:t>Challenges Faced — Solved</a:t>
             </a:r>
           </a:p>
         </p:txBody>
@@ -9237,162 +9238,14 @@
       </p:sp>
       <p:sp>
         <p:nvSpPr>
-          <p:cNvPr id="7" name="TextBox 6"/>
-          <p:cNvSpPr txBox="1"/>
+          <p:cNvPr id="7" name="Rectangle 6"/>
+          <p:cNvSpPr/>
           <p:nvPr/>
         </p:nvSpPr>
         <p:spPr>
           <a:xfrm>
             <a:off x="731520" y="1554480"/>
-            <a:ext cx="10789920" cy="3108960"/>
-          </a:xfrm>
-          <a:prstGeom prst="rect">
-            <a:avLst/>
-          </a:prstGeom>
-          <a:noFill/>
-        </p:spPr>
-        <p:txBody>
-          <a:bodyPr wrap="square">
-            <a:spAutoFit/>
-          </a:bodyPr>
-          <a:lstStyle/>
-          <a:p>
-            <a:pPr>
-              <a:spcAft>
-                <a:spcPts val="1100"/>
-              </a:spcAft>
-            </a:pPr>
-            <a:r>
-              <a:rPr sz="1500" b="1">
-                <a:solidFill>
-                  <a:srgbClr val="FFFFFF"/>
-                </a:solidFill>
-                <a:latin typeface="Calibri"/>
-              </a:rPr>
-              <a:t>Deployment targets: </a:t>
-            </a:r>
-            <a:r>
-              <a:rPr sz="1500">
-                <a:solidFill>
-                  <a:srgbClr val="CBD5E1"/>
-                </a:solidFill>
-                <a:latin typeface="Calibri"/>
-              </a:rPr>
-              <a:t>Supabase (Postgres) + Render (backend) + Vercel (frontend) — all free tier, no code changes.</a:t>
-            </a:r>
-          </a:p>
-          <a:p>
-            <a:pPr>
-              <a:spcAft>
-                <a:spcPts val="1100"/>
-              </a:spcAft>
-            </a:pPr>
-            <a:r>
-              <a:rPr sz="1500" b="1">
-                <a:solidFill>
-                  <a:srgbClr val="FFFFFF"/>
-                </a:solidFill>
-                <a:latin typeface="Calibri"/>
-              </a:rPr>
-              <a:t>Full step-by-step: </a:t>
-            </a:r>
-            <a:r>
-              <a:rPr sz="1500">
-                <a:solidFill>
-                  <a:srgbClr val="CBD5E1"/>
-                </a:solidFill>
-                <a:latin typeface="Calibri"/>
-              </a:rPr>
-              <a:t>docs/deployment_guide.md (CORS via ALLOWED_ORIGINS, RAG index committed, resume stored in Postgres).</a:t>
-            </a:r>
-          </a:p>
-          <a:p>
-            <a:pPr>
-              <a:spcAft>
-                <a:spcPts val="1100"/>
-              </a:spcAft>
-            </a:pPr>
-            <a:r>
-              <a:rPr sz="1500" b="1">
-                <a:solidFill>
-                  <a:srgbClr val="FFFFFF"/>
-                </a:solidFill>
-                <a:latin typeface="Calibri"/>
-              </a:rPr>
-              <a:t>Documentation shipped: </a:t>
-            </a:r>
-            <a:r>
-              <a:rPr sz="1500">
-                <a:solidFill>
-                  <a:srgbClr val="CBD5E1"/>
-                </a:solidFill>
-                <a:latin typeface="Calibri"/>
-              </a:rPr>
-              <a:t>api_contract, user_workflow, project_brief, final_decisions, frontend_developer_guide, deployment_guide, context_export_prompt.</a:t>
-            </a:r>
-          </a:p>
-          <a:p>
-            <a:pPr>
-              <a:spcAft>
-                <a:spcPts val="1100"/>
-              </a:spcAft>
-            </a:pPr>
-            <a:r>
-              <a:rPr sz="1500" b="1">
-                <a:solidFill>
-                  <a:srgbClr val="FFFFFF"/>
-                </a:solidFill>
-                <a:latin typeface="Calibri"/>
-              </a:rPr>
-              <a:t>Repo: </a:t>
-            </a:r>
-            <a:r>
-              <a:rPr sz="1500">
-                <a:solidFill>
-                  <a:srgbClr val="CBD5E1"/>
-                </a:solidFill>
-                <a:latin typeface="Calibri"/>
-              </a:rPr>
-              <a:t>github.com/Jathin-24/LearnPath — 33 commits reflecting the development process.</a:t>
-            </a:r>
-          </a:p>
-          <a:p>
-            <a:pPr>
-              <a:spcAft>
-                <a:spcPts val="1100"/>
-              </a:spcAft>
-            </a:pPr>
-            <a:r>
-              <a:rPr sz="1500" b="1">
-                <a:solidFill>
-                  <a:srgbClr val="FFFFFF"/>
-                </a:solidFill>
-                <a:latin typeface="Calibri"/>
-              </a:rPr>
-              <a:t>This deck + PDF: </a:t>
-            </a:r>
-            <a:r>
-              <a:rPr sz="1500">
-                <a:solidFill>
-                  <a:srgbClr val="CBD5E1"/>
-                </a:solidFill>
-                <a:latin typeface="Calibri"/>
-              </a:rPr>
-              <a:t>one-stop Path A/B + dataset + pipeline explanation for the team.</a:t>
-            </a:r>
-          </a:p>
-        </p:txBody>
-      </p:sp>
-      <p:sp>
-        <p:nvSpPr>
-          <p:cNvPr id="8" name="Rectangle 7"/>
-          <p:cNvSpPr/>
-          <p:nvPr/>
-        </p:nvSpPr>
-        <p:spPr>
-          <a:xfrm>
-            <a:off x="731520" y="4846320"/>
-            <a:ext cx="10789920" cy="1188720"/>
+            <a:ext cx="5303520" cy="1280160"/>
           </a:xfrm>
           <a:prstGeom prst="rect">
             <a:avLst/>
@@ -9429,35 +9282,675 @@
       </p:sp>
       <p:sp>
         <p:nvSpPr>
+          <p:cNvPr id="8" name="TextBox 7"/>
+          <p:cNvSpPr txBox="1"/>
+          <p:nvPr/>
+        </p:nvSpPr>
+        <p:spPr>
+          <a:xfrm>
+            <a:off x="914400" y="1627632"/>
+            <a:ext cx="4937760" cy="365760"/>
+          </a:xfrm>
+          <a:prstGeom prst="rect">
+            <a:avLst/>
+          </a:prstGeom>
+          <a:noFill/>
+        </p:spPr>
+        <p:txBody>
+          <a:bodyPr wrap="square" anchor="t">
+            <a:spAutoFit/>
+          </a:bodyPr>
+          <a:lstStyle/>
+          <a:p>
+            <a:pPr algn="l"/>
+            <a:r>
+              <a:rPr sz="1400" b="1">
+                <a:solidFill>
+                  <a:srgbClr val="FBBF24"/>
+                </a:solidFill>
+                <a:latin typeface="Calibri"/>
+              </a:rPr>
+              <a:t>No metadata in the dataset</a:t>
+            </a:r>
+          </a:p>
+        </p:txBody>
+      </p:sp>
+      <p:sp>
+        <p:nvSpPr>
           <p:cNvPr id="9" name="TextBox 8"/>
           <p:cNvSpPr txBox="1"/>
           <p:nvPr/>
         </p:nvSpPr>
         <p:spPr>
           <a:xfrm>
-            <a:off x="960120" y="5074920"/>
-            <a:ext cx="10332720" cy="822960"/>
-          </a:xfrm>
-          <a:prstGeom prst="rect">
-            <a:avLst/>
-          </a:prstGeom>
-          <a:noFill/>
-        </p:spPr>
-        <p:txBody>
-          <a:bodyPr wrap="square" anchor="t">
-            <a:spAutoFit/>
-          </a:bodyPr>
+            <a:off x="914400" y="1993392"/>
+            <a:ext cx="4937760" cy="777240"/>
+          </a:xfrm>
+          <a:prstGeom prst="rect">
+            <a:avLst/>
+          </a:prstGeom>
+          <a:noFill/>
+        </p:spPr>
+        <p:txBody>
+          <a:bodyPr wrap="square" anchor="t">
+            <a:spAutoFit/>
+          </a:bodyPr>
+          <a:lstStyle/>
+          <a:p>
+            <a:pPr algn="l"/>
+            <a:r>
+              <a:rPr sz="1150" b="0">
+                <a:solidFill>
+                  <a:srgbClr val="CBD5E1"/>
+                </a:solidFill>
+                <a:latin typeface="Calibri"/>
+              </a:rPr>
+              <a:t>109,776 bare reviews. One-time enrichment: concepts, difficulty, strengths/weaknesses, prerequisite DAG — ~81 LLM calls, run once, 0 parse errors.</a:t>
+            </a:r>
+          </a:p>
+        </p:txBody>
+      </p:sp>
+      <p:sp>
+        <p:nvSpPr>
+          <p:cNvPr id="10" name="Rectangle 9"/>
+          <p:cNvSpPr/>
+          <p:nvPr/>
+        </p:nvSpPr>
+        <p:spPr>
+          <a:xfrm>
+            <a:off x="6217920" y="1554480"/>
+            <a:ext cx="5303520" cy="1280160"/>
+          </a:xfrm>
+          <a:prstGeom prst="rect">
+            <a:avLst/>
+          </a:prstGeom>
+          <a:solidFill>
+            <a:srgbClr val="1E293B"/>
+          </a:solidFill>
+          <a:ln>
+            <a:noFill/>
+          </a:ln>
+          <a:effectLst/>
+        </p:spPr>
+        <p:style>
+          <a:lnRef idx="1">
+            <a:schemeClr val="accent1"/>
+          </a:lnRef>
+          <a:fillRef idx="3">
+            <a:schemeClr val="accent1"/>
+          </a:fillRef>
+          <a:effectRef idx="2">
+            <a:schemeClr val="accent1"/>
+          </a:effectRef>
+          <a:fontRef idx="minor">
+            <a:schemeClr val="lt1"/>
+          </a:fontRef>
+        </p:style>
+        <p:txBody>
+          <a:bodyPr rtlCol="0" anchor="ctr"/>
           <a:lstStyle/>
           <a:p>
             <a:pPr algn="ctr"/>
-            <a:r>
-              <a:rPr sz="2000" b="1">
-                <a:solidFill>
-                  <a:srgbClr val="34D399"/>
-                </a:solidFill>
-                <a:latin typeface="Calibri"/>
-              </a:rPr>
-              <a:t>"We don't recommend what to learn. We continuously decide what you should learn next."</a:t>
+          </a:p>
+        </p:txBody>
+      </p:sp>
+      <p:sp>
+        <p:nvSpPr>
+          <p:cNvPr id="11" name="TextBox 10"/>
+          <p:cNvSpPr txBox="1"/>
+          <p:nvPr/>
+        </p:nvSpPr>
+        <p:spPr>
+          <a:xfrm>
+            <a:off x="6400800" y="1627632"/>
+            <a:ext cx="4937760" cy="365760"/>
+          </a:xfrm>
+          <a:prstGeom prst="rect">
+            <a:avLst/>
+          </a:prstGeom>
+          <a:noFill/>
+        </p:spPr>
+        <p:txBody>
+          <a:bodyPr wrap="square" anchor="t">
+            <a:spAutoFit/>
+          </a:bodyPr>
+          <a:lstStyle/>
+          <a:p>
+            <a:pPr algn="l"/>
+            <a:r>
+              <a:rPr sz="1400" b="1">
+                <a:solidFill>
+                  <a:srgbClr val="FBBF24"/>
+                </a:solidFill>
+                <a:latin typeface="Calibri"/>
+              </a:rPr>
+              <a:t>Render 512MB free-tier memory</a:t>
+            </a:r>
+          </a:p>
+        </p:txBody>
+      </p:sp>
+      <p:sp>
+        <p:nvSpPr>
+          <p:cNvPr id="12" name="TextBox 11"/>
+          <p:cNvSpPr txBox="1"/>
+          <p:nvPr/>
+        </p:nvSpPr>
+        <p:spPr>
+          <a:xfrm>
+            <a:off x="6400800" y="1993392"/>
+            <a:ext cx="4937760" cy="777240"/>
+          </a:xfrm>
+          <a:prstGeom prst="rect">
+            <a:avLst/>
+          </a:prstGeom>
+          <a:noFill/>
+        </p:spPr>
+        <p:txBody>
+          <a:bodyPr wrap="square" anchor="t">
+            <a:spAutoFit/>
+          </a:bodyPr>
+          <a:lstStyle/>
+          <a:p>
+            <a:pPr algn="l"/>
+            <a:r>
+              <a:rPr sz="1150" b="0">
+                <a:solidFill>
+                  <a:srgbClr val="CBD5E1"/>
+                </a:solidFill>
+                <a:latin typeface="Calibri"/>
+              </a:rPr>
+              <a:t>torch + sentence-transformers blew the budget → TF-IDF + FAISS; index committed — no model download on the server.</a:t>
+            </a:r>
+          </a:p>
+        </p:txBody>
+      </p:sp>
+      <p:sp>
+        <p:nvSpPr>
+          <p:cNvPr id="13" name="Rectangle 12"/>
+          <p:cNvSpPr/>
+          <p:nvPr/>
+        </p:nvSpPr>
+        <p:spPr>
+          <a:xfrm>
+            <a:off x="731520" y="2971800"/>
+            <a:ext cx="5303520" cy="1280160"/>
+          </a:xfrm>
+          <a:prstGeom prst="rect">
+            <a:avLst/>
+          </a:prstGeom>
+          <a:solidFill>
+            <a:srgbClr val="1E293B"/>
+          </a:solidFill>
+          <a:ln>
+            <a:noFill/>
+          </a:ln>
+          <a:effectLst/>
+        </p:spPr>
+        <p:style>
+          <a:lnRef idx="1">
+            <a:schemeClr val="accent1"/>
+          </a:lnRef>
+          <a:fillRef idx="3">
+            <a:schemeClr val="accent1"/>
+          </a:fillRef>
+          <a:effectRef idx="2">
+            <a:schemeClr val="accent1"/>
+          </a:effectRef>
+          <a:fontRef idx="minor">
+            <a:schemeClr val="lt1"/>
+          </a:fontRef>
+        </p:style>
+        <p:txBody>
+          <a:bodyPr rtlCol="0" anchor="ctr"/>
+          <a:lstStyle/>
+          <a:p>
+            <a:pPr algn="ctr"/>
+          </a:p>
+        </p:txBody>
+      </p:sp>
+      <p:sp>
+        <p:nvSpPr>
+          <p:cNvPr id="14" name="TextBox 13"/>
+          <p:cNvSpPr txBox="1"/>
+          <p:nvPr/>
+        </p:nvSpPr>
+        <p:spPr>
+          <a:xfrm>
+            <a:off x="914400" y="3044952"/>
+            <a:ext cx="4937760" cy="365760"/>
+          </a:xfrm>
+          <a:prstGeom prst="rect">
+            <a:avLst/>
+          </a:prstGeom>
+          <a:noFill/>
+        </p:spPr>
+        <p:txBody>
+          <a:bodyPr wrap="square" anchor="t">
+            <a:spAutoFit/>
+          </a:bodyPr>
+          <a:lstStyle/>
+          <a:p>
+            <a:pPr algn="l"/>
+            <a:r>
+              <a:rPr sz="1400" b="1">
+                <a:solidFill>
+                  <a:srgbClr val="FBBF24"/>
+                </a:solidFill>
+                <a:latin typeface="Calibri"/>
+              </a:rPr>
+              <a:t>Python 3.14 build crash</a:t>
+            </a:r>
+          </a:p>
+        </p:txBody>
+      </p:sp>
+      <p:sp>
+        <p:nvSpPr>
+          <p:cNvPr id="15" name="TextBox 14"/>
+          <p:cNvSpPr txBox="1"/>
+          <p:nvPr/>
+        </p:nvSpPr>
+        <p:spPr>
+          <a:xfrm>
+            <a:off x="914400" y="3410712"/>
+            <a:ext cx="4937760" cy="777240"/>
+          </a:xfrm>
+          <a:prstGeom prst="rect">
+            <a:avLst/>
+          </a:prstGeom>
+          <a:noFill/>
+        </p:spPr>
+        <p:txBody>
+          <a:bodyPr wrap="square" anchor="t">
+            <a:spAutoFit/>
+          </a:bodyPr>
+          <a:lstStyle/>
+          <a:p>
+            <a:pPr algn="l"/>
+            <a:r>
+              <a:rPr sz="1150" b="0">
+                <a:solidFill>
+                  <a:srgbClr val="CBD5E1"/>
+                </a:solidFill>
+                <a:latin typeface="Calibri"/>
+              </a:rPr>
+              <a:t>pydantic-core had no 3.14 wheel → Rust compile failed → pinned 3.12.11 (.python-version + PYTHON_VERSION env).</a:t>
+            </a:r>
+          </a:p>
+        </p:txBody>
+      </p:sp>
+      <p:sp>
+        <p:nvSpPr>
+          <p:cNvPr id="16" name="Rectangle 15"/>
+          <p:cNvSpPr/>
+          <p:nvPr/>
+        </p:nvSpPr>
+        <p:spPr>
+          <a:xfrm>
+            <a:off x="6217920" y="2971800"/>
+            <a:ext cx="5303520" cy="1280160"/>
+          </a:xfrm>
+          <a:prstGeom prst="rect">
+            <a:avLst/>
+          </a:prstGeom>
+          <a:solidFill>
+            <a:srgbClr val="1E293B"/>
+          </a:solidFill>
+          <a:ln>
+            <a:noFill/>
+          </a:ln>
+          <a:effectLst/>
+        </p:spPr>
+        <p:style>
+          <a:lnRef idx="1">
+            <a:schemeClr val="accent1"/>
+          </a:lnRef>
+          <a:fillRef idx="3">
+            <a:schemeClr val="accent1"/>
+          </a:fillRef>
+          <a:effectRef idx="2">
+            <a:schemeClr val="accent1"/>
+          </a:effectRef>
+          <a:fontRef idx="minor">
+            <a:schemeClr val="lt1"/>
+          </a:fontRef>
+        </p:style>
+        <p:txBody>
+          <a:bodyPr rtlCol="0" anchor="ctr"/>
+          <a:lstStyle/>
+          <a:p>
+            <a:pPr algn="ctr"/>
+          </a:p>
+        </p:txBody>
+      </p:sp>
+      <p:sp>
+        <p:nvSpPr>
+          <p:cNvPr id="17" name="TextBox 16"/>
+          <p:cNvSpPr txBox="1"/>
+          <p:nvPr/>
+        </p:nvSpPr>
+        <p:spPr>
+          <a:xfrm>
+            <a:off x="6400800" y="3044952"/>
+            <a:ext cx="4937760" cy="365760"/>
+          </a:xfrm>
+          <a:prstGeom prst="rect">
+            <a:avLst/>
+          </a:prstGeom>
+          <a:noFill/>
+        </p:spPr>
+        <p:txBody>
+          <a:bodyPr wrap="square" anchor="t">
+            <a:spAutoFit/>
+          </a:bodyPr>
+          <a:lstStyle/>
+          <a:p>
+            <a:pPr algn="l"/>
+            <a:r>
+              <a:rPr sz="1400" b="1">
+                <a:solidFill>
+                  <a:srgbClr val="FBBF24"/>
+                </a:solidFill>
+                <a:latin typeface="Calibri"/>
+              </a:rPr>
+              <a:t>LLM flakiness &amp; rate limits</a:t>
+            </a:r>
+          </a:p>
+        </p:txBody>
+      </p:sp>
+      <p:sp>
+        <p:nvSpPr>
+          <p:cNvPr id="18" name="TextBox 17"/>
+          <p:cNvSpPr txBox="1"/>
+          <p:nvPr/>
+        </p:nvSpPr>
+        <p:spPr>
+          <a:xfrm>
+            <a:off x="6400800" y="3410712"/>
+            <a:ext cx="4937760" cy="777240"/>
+          </a:xfrm>
+          <a:prstGeom prst="rect">
+            <a:avLst/>
+          </a:prstGeom>
+          <a:noFill/>
+        </p:spPr>
+        <p:txBody>
+          <a:bodyPr wrap="square" anchor="t">
+            <a:spAutoFit/>
+          </a:bodyPr>
+          <a:lstStyle/>
+          <a:p>
+            <a:pPr algn="l"/>
+            <a:r>
+              <a:rPr sz="1150" b="0">
+                <a:solidFill>
+                  <a:srgbClr val="CBD5E1"/>
+                </a:solidFill>
+                <a:latin typeface="Calibri"/>
+              </a:rPr>
+              <a:t>priority multi-provider client — HEALTHY / COOLING_DOWN / DEAD states, 429 → 60s cooldown, backoff, auto-failover, friendly 502s.</a:t>
+            </a:r>
+          </a:p>
+        </p:txBody>
+      </p:sp>
+      <p:sp>
+        <p:nvSpPr>
+          <p:cNvPr id="19" name="Rectangle 18"/>
+          <p:cNvSpPr/>
+          <p:nvPr/>
+        </p:nvSpPr>
+        <p:spPr>
+          <a:xfrm>
+            <a:off x="731520" y="4389120"/>
+            <a:ext cx="5303520" cy="1280160"/>
+          </a:xfrm>
+          <a:prstGeom prst="rect">
+            <a:avLst/>
+          </a:prstGeom>
+          <a:solidFill>
+            <a:srgbClr val="1E293B"/>
+          </a:solidFill>
+          <a:ln>
+            <a:noFill/>
+          </a:ln>
+          <a:effectLst/>
+        </p:spPr>
+        <p:style>
+          <a:lnRef idx="1">
+            <a:schemeClr val="accent1"/>
+          </a:lnRef>
+          <a:fillRef idx="3">
+            <a:schemeClr val="accent1"/>
+          </a:fillRef>
+          <a:effectRef idx="2">
+            <a:schemeClr val="accent1"/>
+          </a:effectRef>
+          <a:fontRef idx="minor">
+            <a:schemeClr val="lt1"/>
+          </a:fontRef>
+        </p:style>
+        <p:txBody>
+          <a:bodyPr rtlCol="0" anchor="ctr"/>
+          <a:lstStyle/>
+          <a:p>
+            <a:pPr algn="ctr"/>
+          </a:p>
+        </p:txBody>
+      </p:sp>
+      <p:sp>
+        <p:nvSpPr>
+          <p:cNvPr id="20" name="TextBox 19"/>
+          <p:cNvSpPr txBox="1"/>
+          <p:nvPr/>
+        </p:nvSpPr>
+        <p:spPr>
+          <a:xfrm>
+            <a:off x="914400" y="4462272"/>
+            <a:ext cx="4937760" cy="365760"/>
+          </a:xfrm>
+          <a:prstGeom prst="rect">
+            <a:avLst/>
+          </a:prstGeom>
+          <a:noFill/>
+        </p:spPr>
+        <p:txBody>
+          <a:bodyPr wrap="square" anchor="t">
+            <a:spAutoFit/>
+          </a:bodyPr>
+          <a:lstStyle/>
+          <a:p>
+            <a:pPr algn="l"/>
+            <a:r>
+              <a:rPr sz="1400" b="1">
+                <a:solidFill>
+                  <a:srgbClr val="FBBF24"/>
+                </a:solidFill>
+                <a:latin typeface="Calibri"/>
+              </a:rPr>
+              <a:t>Lexical vs semantic mismatch</a:t>
+            </a:r>
+          </a:p>
+        </p:txBody>
+      </p:sp>
+      <p:sp>
+        <p:nvSpPr>
+          <p:cNvPr id="21" name="TextBox 20"/>
+          <p:cNvSpPr txBox="1"/>
+          <p:nvPr/>
+        </p:nvSpPr>
+        <p:spPr>
+          <a:xfrm>
+            <a:off x="914400" y="4828032"/>
+            <a:ext cx="4937760" cy="777240"/>
+          </a:xfrm>
+          <a:prstGeom prst="rect">
+            <a:avLst/>
+          </a:prstGeom>
+          <a:noFill/>
+        </p:spPr>
+        <p:txBody>
+          <a:bodyPr wrap="square" anchor="t">
+            <a:spAutoFit/>
+          </a:bodyPr>
+          <a:lstStyle/>
+          <a:p>
+            <a:pPr algn="l"/>
+            <a:r>
+              <a:rPr sz="1150" b="0">
+                <a:solidFill>
+                  <a:srgbClr val="CBD5E1"/>
+                </a:solidFill>
+                <a:latin typeface="Calibri"/>
+              </a:rPr>
+              <a:t>TF-IDF is lexical; evidence-based 0.35 floor + whole-goal web fallback; the LLM does semantic selection on top of retrieval.</a:t>
+            </a:r>
+          </a:p>
+        </p:txBody>
+      </p:sp>
+      <p:sp>
+        <p:nvSpPr>
+          <p:cNvPr id="22" name="Rectangle 21"/>
+          <p:cNvSpPr/>
+          <p:nvPr/>
+        </p:nvSpPr>
+        <p:spPr>
+          <a:xfrm>
+            <a:off x="6217920" y="4389120"/>
+            <a:ext cx="5303520" cy="1280160"/>
+          </a:xfrm>
+          <a:prstGeom prst="rect">
+            <a:avLst/>
+          </a:prstGeom>
+          <a:solidFill>
+            <a:srgbClr val="1E293B"/>
+          </a:solidFill>
+          <a:ln>
+            <a:noFill/>
+          </a:ln>
+          <a:effectLst/>
+        </p:spPr>
+        <p:style>
+          <a:lnRef idx="1">
+            <a:schemeClr val="accent1"/>
+          </a:lnRef>
+          <a:fillRef idx="3">
+            <a:schemeClr val="accent1"/>
+          </a:fillRef>
+          <a:effectRef idx="2">
+            <a:schemeClr val="accent1"/>
+          </a:effectRef>
+          <a:fontRef idx="minor">
+            <a:schemeClr val="lt1"/>
+          </a:fontRef>
+        </p:style>
+        <p:txBody>
+          <a:bodyPr rtlCol="0" anchor="ctr"/>
+          <a:lstStyle/>
+          <a:p>
+            <a:pPr algn="ctr"/>
+          </a:p>
+        </p:txBody>
+      </p:sp>
+      <p:sp>
+        <p:nvSpPr>
+          <p:cNvPr id="23" name="TextBox 22"/>
+          <p:cNvSpPr txBox="1"/>
+          <p:nvPr/>
+        </p:nvSpPr>
+        <p:spPr>
+          <a:xfrm>
+            <a:off x="6400800" y="4462272"/>
+            <a:ext cx="4937760" cy="365760"/>
+          </a:xfrm>
+          <a:prstGeom prst="rect">
+            <a:avLst/>
+          </a:prstGeom>
+          <a:noFill/>
+        </p:spPr>
+        <p:txBody>
+          <a:bodyPr wrap="square" anchor="t">
+            <a:spAutoFit/>
+          </a:bodyPr>
+          <a:lstStyle/>
+          <a:p>
+            <a:pPr algn="l"/>
+            <a:r>
+              <a:rPr sz="1400" b="1">
+                <a:solidFill>
+                  <a:srgbClr val="FBBF24"/>
+                </a:solidFill>
+                <a:latin typeface="Calibri"/>
+              </a:rPr>
+              <a:t>Deployment gotchas</a:t>
+            </a:r>
+          </a:p>
+        </p:txBody>
+      </p:sp>
+      <p:sp>
+        <p:nvSpPr>
+          <p:cNvPr id="24" name="TextBox 23"/>
+          <p:cNvSpPr txBox="1"/>
+          <p:nvPr/>
+        </p:nvSpPr>
+        <p:spPr>
+          <a:xfrm>
+            <a:off x="6400800" y="4828032"/>
+            <a:ext cx="4937760" cy="777240"/>
+          </a:xfrm>
+          <a:prstGeom prst="rect">
+            <a:avLst/>
+          </a:prstGeom>
+          <a:noFill/>
+        </p:spPr>
+        <p:txBody>
+          <a:bodyPr wrap="square" anchor="t">
+            <a:spAutoFit/>
+          </a:bodyPr>
+          <a:lstStyle/>
+          <a:p>
+            <a:pPr algn="l"/>
+            <a:r>
+              <a:rPr sz="1150" b="0">
+                <a:solidFill>
+                  <a:srgbClr val="CBD5E1"/>
+                </a:solidFill>
+                <a:latin typeface="Calibri"/>
+              </a:rPr>
+              <a:t>a 500-on-upload regression and a stray CR in Vercel env breaking the API URL — both caught and fixed against the live deploy.</a:t>
+            </a:r>
+          </a:p>
+        </p:txBody>
+      </p:sp>
+      <p:sp>
+        <p:nvSpPr>
+          <p:cNvPr id="25" name="TextBox 24"/>
+          <p:cNvSpPr txBox="1"/>
+          <p:nvPr/>
+        </p:nvSpPr>
+        <p:spPr>
+          <a:xfrm>
+            <a:off x="731520" y="5852160"/>
+            <a:ext cx="10789920" cy="548640"/>
+          </a:xfrm>
+          <a:prstGeom prst="rect">
+            <a:avLst/>
+          </a:prstGeom>
+          <a:noFill/>
+        </p:spPr>
+        <p:txBody>
+          <a:bodyPr wrap="square" anchor="t">
+            <a:spAutoFit/>
+          </a:bodyPr>
+          <a:lstStyle/>
+          <a:p>
+            <a:pPr algn="l"/>
+            <a:r>
+              <a:rPr sz="1300" b="0">
+                <a:solidFill>
+                  <a:srgbClr val="94A3B8"/>
+                </a:solidFill>
+                <a:latin typeface="Calibri"/>
+              </a:rPr>
+              <a:t>Takeaway: free-tier limits forced real tradeoffs — the system shipped lighter, cheaper and more robust for it.</a:t>
             </a:r>
           </a:p>
         </p:txBody>
@@ -9906,6 +10399,444 @@
                 <a:latin typeface="Calibri"/>
               </a:rPr>
               <a:t>How do we understand a learner's profile, analyze their goal, identify skill gaps, and generate a structured roadmap of courses, projects and assessments tailored to the individual — that adapts as they learn?</a:t>
+            </a:r>
+          </a:p>
+        </p:txBody>
+      </p:sp>
+    </p:spTree>
+  </p:cSld>
+  <p:clrMapOvr>
+    <a:masterClrMapping/>
+  </p:clrMapOvr>
+</p:sld>
+</file>
+
+<file path=ppt/slides/slide20.xml><?xml version="1.0" encoding="utf-8"?>
+<p:sld xmlns:a="http://schemas.openxmlformats.org/drawingml/2006/main" xmlns:p="http://schemas.openxmlformats.org/presentationml/2006/main" xmlns:r="http://schemas.openxmlformats.org/officeDocument/2006/relationships">
+  <p:cSld>
+    <p:spTree>
+      <p:nvGrpSpPr>
+        <p:cNvPr id="1" name=""/>
+        <p:cNvGrpSpPr/>
+        <p:nvPr/>
+      </p:nvGrpSpPr>
+      <p:grpSpPr/>
+      <p:sp>
+        <p:nvSpPr>
+          <p:cNvPr id="2" name="Rectangle 1"/>
+          <p:cNvSpPr/>
+          <p:nvPr/>
+        </p:nvSpPr>
+        <p:spPr>
+          <a:xfrm>
+            <a:off x="0" y="0"/>
+            <a:ext cx="12191695" cy="6858000"/>
+          </a:xfrm>
+          <a:prstGeom prst="rect">
+            <a:avLst/>
+          </a:prstGeom>
+          <a:solidFill>
+            <a:srgbClr val="020617"/>
+          </a:solidFill>
+          <a:ln>
+            <a:noFill/>
+          </a:ln>
+          <a:effectLst/>
+        </p:spPr>
+        <p:style>
+          <a:lnRef idx="1">
+            <a:schemeClr val="accent1"/>
+          </a:lnRef>
+          <a:fillRef idx="3">
+            <a:schemeClr val="accent1"/>
+          </a:fillRef>
+          <a:effectRef idx="2">
+            <a:schemeClr val="accent1"/>
+          </a:effectRef>
+          <a:fontRef idx="minor">
+            <a:schemeClr val="lt1"/>
+          </a:fontRef>
+        </p:style>
+        <p:txBody>
+          <a:bodyPr rtlCol="0" anchor="ctr"/>
+          <a:lstStyle/>
+          <a:p>
+            <a:pPr algn="ctr"/>
+          </a:p>
+        </p:txBody>
+      </p:sp>
+      <p:sp>
+        <p:nvSpPr>
+          <p:cNvPr id="3" name="Rectangle 2"/>
+          <p:cNvSpPr/>
+          <p:nvPr/>
+        </p:nvSpPr>
+        <p:spPr>
+          <a:xfrm>
+            <a:off x="0" y="0"/>
+            <a:ext cx="12191695" cy="109728"/>
+          </a:xfrm>
+          <a:prstGeom prst="rect">
+            <a:avLst/>
+          </a:prstGeom>
+          <a:solidFill>
+            <a:srgbClr val="34D399"/>
+          </a:solidFill>
+          <a:ln>
+            <a:noFill/>
+          </a:ln>
+          <a:effectLst/>
+        </p:spPr>
+        <p:style>
+          <a:lnRef idx="1">
+            <a:schemeClr val="accent1"/>
+          </a:lnRef>
+          <a:fillRef idx="3">
+            <a:schemeClr val="accent1"/>
+          </a:fillRef>
+          <a:effectRef idx="2">
+            <a:schemeClr val="accent1"/>
+          </a:effectRef>
+          <a:fontRef idx="minor">
+            <a:schemeClr val="lt1"/>
+          </a:fontRef>
+        </p:style>
+        <p:txBody>
+          <a:bodyPr rtlCol="0" anchor="ctr"/>
+          <a:lstStyle/>
+          <a:p>
+            <a:pPr algn="ctr"/>
+          </a:p>
+        </p:txBody>
+      </p:sp>
+      <p:sp>
+        <p:nvSpPr>
+          <p:cNvPr id="4" name="TextBox 3"/>
+          <p:cNvSpPr txBox="1"/>
+          <p:nvPr/>
+        </p:nvSpPr>
+        <p:spPr>
+          <a:xfrm>
+            <a:off x="640080" y="411480"/>
+            <a:ext cx="10058400" cy="365760"/>
+          </a:xfrm>
+          <a:prstGeom prst="rect">
+            <a:avLst/>
+          </a:prstGeom>
+          <a:noFill/>
+        </p:spPr>
+        <p:txBody>
+          <a:bodyPr wrap="square" anchor="t">
+            <a:spAutoFit/>
+          </a:bodyPr>
+          <a:lstStyle/>
+          <a:p>
+            <a:pPr algn="l"/>
+            <a:r>
+              <a:rPr sz="1400" b="1">
+                <a:solidFill>
+                  <a:srgbClr val="34D399"/>
+                </a:solidFill>
+                <a:latin typeface="Calibri"/>
+              </a:rPr>
+              <a:t>DEPLOYMENT</a:t>
+            </a:r>
+          </a:p>
+        </p:txBody>
+      </p:sp>
+      <p:sp>
+        <p:nvSpPr>
+          <p:cNvPr id="5" name="TextBox 4"/>
+          <p:cNvSpPr txBox="1"/>
+          <p:nvPr/>
+        </p:nvSpPr>
+        <p:spPr>
+          <a:xfrm>
+            <a:off x="640080" y="777240"/>
+            <a:ext cx="10972800" cy="731520"/>
+          </a:xfrm>
+          <a:prstGeom prst="rect">
+            <a:avLst/>
+          </a:prstGeom>
+          <a:noFill/>
+        </p:spPr>
+        <p:txBody>
+          <a:bodyPr wrap="square" anchor="t">
+            <a:spAutoFit/>
+          </a:bodyPr>
+          <a:lstStyle/>
+          <a:p>
+            <a:pPr algn="l"/>
+            <a:r>
+              <a:rPr sz="3200" b="1">
+                <a:solidFill>
+                  <a:srgbClr val="FFFFFF"/>
+                </a:solidFill>
+                <a:latin typeface="Calibri"/>
+              </a:rPr>
+              <a:t>Deployment &amp; Deliverables</a:t>
+            </a:r>
+          </a:p>
+        </p:txBody>
+      </p:sp>
+      <p:sp>
+        <p:nvSpPr>
+          <p:cNvPr id="6" name="TextBox 5"/>
+          <p:cNvSpPr txBox="1"/>
+          <p:nvPr/>
+        </p:nvSpPr>
+        <p:spPr>
+          <a:xfrm>
+            <a:off x="640080" y="6446520"/>
+            <a:ext cx="10881360" cy="274320"/>
+          </a:xfrm>
+          <a:prstGeom prst="rect">
+            <a:avLst/>
+          </a:prstGeom>
+          <a:noFill/>
+        </p:spPr>
+        <p:txBody>
+          <a:bodyPr wrap="square" anchor="t">
+            <a:spAutoFit/>
+          </a:bodyPr>
+          <a:lstStyle/>
+          <a:p>
+            <a:pPr algn="r"/>
+            <a:r>
+              <a:rPr sz="1100" b="0">
+                <a:solidFill>
+                  <a:srgbClr val="94A3B8"/>
+                </a:solidFill>
+                <a:latin typeface="Calibri"/>
+              </a:rPr>
+              <a:t>LearnPath — HCLTech AMPLIFIED Round 2  |  20</a:t>
+            </a:r>
+          </a:p>
+        </p:txBody>
+      </p:sp>
+      <p:sp>
+        <p:nvSpPr>
+          <p:cNvPr id="7" name="TextBox 6"/>
+          <p:cNvSpPr txBox="1"/>
+          <p:nvPr/>
+        </p:nvSpPr>
+        <p:spPr>
+          <a:xfrm>
+            <a:off x="731520" y="1554480"/>
+            <a:ext cx="10789920" cy="3108960"/>
+          </a:xfrm>
+          <a:prstGeom prst="rect">
+            <a:avLst/>
+          </a:prstGeom>
+          <a:noFill/>
+        </p:spPr>
+        <p:txBody>
+          <a:bodyPr wrap="square">
+            <a:spAutoFit/>
+          </a:bodyPr>
+          <a:lstStyle/>
+          <a:p>
+            <a:pPr>
+              <a:spcAft>
+                <a:spcPts val="1100"/>
+              </a:spcAft>
+            </a:pPr>
+            <a:r>
+              <a:rPr sz="1500" b="1">
+                <a:solidFill>
+                  <a:srgbClr val="FFFFFF"/>
+                </a:solidFill>
+                <a:latin typeface="Calibri"/>
+              </a:rPr>
+              <a:t>Deployment targets: </a:t>
+            </a:r>
+            <a:r>
+              <a:rPr sz="1500">
+                <a:solidFill>
+                  <a:srgbClr val="CBD5E1"/>
+                </a:solidFill>
+                <a:latin typeface="Calibri"/>
+              </a:rPr>
+              <a:t>Supabase (Postgres) + Render (backend) + Vercel (frontend) — all free tier, no code changes.</a:t>
+            </a:r>
+          </a:p>
+          <a:p>
+            <a:pPr>
+              <a:spcAft>
+                <a:spcPts val="1100"/>
+              </a:spcAft>
+            </a:pPr>
+            <a:r>
+              <a:rPr sz="1500" b="1">
+                <a:solidFill>
+                  <a:srgbClr val="FFFFFF"/>
+                </a:solidFill>
+                <a:latin typeface="Calibri"/>
+              </a:rPr>
+              <a:t>Full step-by-step: </a:t>
+            </a:r>
+            <a:r>
+              <a:rPr sz="1500">
+                <a:solidFill>
+                  <a:srgbClr val="CBD5E1"/>
+                </a:solidFill>
+                <a:latin typeface="Calibri"/>
+              </a:rPr>
+              <a:t>docs/deployment_guide.md (CORS via ALLOWED_ORIGINS, RAG index committed, resume stored in Postgres).</a:t>
+            </a:r>
+          </a:p>
+          <a:p>
+            <a:pPr>
+              <a:spcAft>
+                <a:spcPts val="1100"/>
+              </a:spcAft>
+            </a:pPr>
+            <a:r>
+              <a:rPr sz="1500" b="1">
+                <a:solidFill>
+                  <a:srgbClr val="FFFFFF"/>
+                </a:solidFill>
+                <a:latin typeface="Calibri"/>
+              </a:rPr>
+              <a:t>Documentation shipped: </a:t>
+            </a:r>
+            <a:r>
+              <a:rPr sz="1500">
+                <a:solidFill>
+                  <a:srgbClr val="CBD5E1"/>
+                </a:solidFill>
+                <a:latin typeface="Calibri"/>
+              </a:rPr>
+              <a:t>api_contract, user_workflow, project_brief, final_decisions, frontend_developer_guide, deployment_guide, context_export_prompt.</a:t>
+            </a:r>
+          </a:p>
+          <a:p>
+            <a:pPr>
+              <a:spcAft>
+                <a:spcPts val="1100"/>
+              </a:spcAft>
+            </a:pPr>
+            <a:r>
+              <a:rPr sz="1500" b="1">
+                <a:solidFill>
+                  <a:srgbClr val="FFFFFF"/>
+                </a:solidFill>
+                <a:latin typeface="Calibri"/>
+              </a:rPr>
+              <a:t>Repo: </a:t>
+            </a:r>
+            <a:r>
+              <a:rPr sz="1500">
+                <a:solidFill>
+                  <a:srgbClr val="CBD5E1"/>
+                </a:solidFill>
+                <a:latin typeface="Calibri"/>
+              </a:rPr>
+              <a:t>github.com/Jathin-24/LearnPath — 33 commits reflecting the development process.</a:t>
+            </a:r>
+          </a:p>
+          <a:p>
+            <a:pPr>
+              <a:spcAft>
+                <a:spcPts val="1100"/>
+              </a:spcAft>
+            </a:pPr>
+            <a:r>
+              <a:rPr sz="1500" b="1">
+                <a:solidFill>
+                  <a:srgbClr val="FFFFFF"/>
+                </a:solidFill>
+                <a:latin typeface="Calibri"/>
+              </a:rPr>
+              <a:t>This deck + PDF: </a:t>
+            </a:r>
+            <a:r>
+              <a:rPr sz="1500">
+                <a:solidFill>
+                  <a:srgbClr val="CBD5E1"/>
+                </a:solidFill>
+                <a:latin typeface="Calibri"/>
+              </a:rPr>
+              <a:t>one-stop Path A/B + dataset + pipeline explanation for the team.</a:t>
+            </a:r>
+          </a:p>
+        </p:txBody>
+      </p:sp>
+      <p:sp>
+        <p:nvSpPr>
+          <p:cNvPr id="8" name="Rectangle 7"/>
+          <p:cNvSpPr/>
+          <p:nvPr/>
+        </p:nvSpPr>
+        <p:spPr>
+          <a:xfrm>
+            <a:off x="731520" y="4846320"/>
+            <a:ext cx="10789920" cy="1188720"/>
+          </a:xfrm>
+          <a:prstGeom prst="rect">
+            <a:avLst/>
+          </a:prstGeom>
+          <a:solidFill>
+            <a:srgbClr val="1E293B"/>
+          </a:solidFill>
+          <a:ln>
+            <a:noFill/>
+          </a:ln>
+          <a:effectLst/>
+        </p:spPr>
+        <p:style>
+          <a:lnRef idx="1">
+            <a:schemeClr val="accent1"/>
+          </a:lnRef>
+          <a:fillRef idx="3">
+            <a:schemeClr val="accent1"/>
+          </a:fillRef>
+          <a:effectRef idx="2">
+            <a:schemeClr val="accent1"/>
+          </a:effectRef>
+          <a:fontRef idx="minor">
+            <a:schemeClr val="lt1"/>
+          </a:fontRef>
+        </p:style>
+        <p:txBody>
+          <a:bodyPr rtlCol="0" anchor="ctr"/>
+          <a:lstStyle/>
+          <a:p>
+            <a:pPr algn="ctr"/>
+          </a:p>
+        </p:txBody>
+      </p:sp>
+      <p:sp>
+        <p:nvSpPr>
+          <p:cNvPr id="9" name="TextBox 8"/>
+          <p:cNvSpPr txBox="1"/>
+          <p:nvPr/>
+        </p:nvSpPr>
+        <p:spPr>
+          <a:xfrm>
+            <a:off x="960120" y="5074920"/>
+            <a:ext cx="10332720" cy="822960"/>
+          </a:xfrm>
+          <a:prstGeom prst="rect">
+            <a:avLst/>
+          </a:prstGeom>
+          <a:noFill/>
+        </p:spPr>
+        <p:txBody>
+          <a:bodyPr wrap="square" anchor="t">
+            <a:spAutoFit/>
+          </a:bodyPr>
+          <a:lstStyle/>
+          <a:p>
+            <a:pPr algn="ctr"/>
+            <a:r>
+              <a:rPr sz="2000" b="1">
+                <a:solidFill>
+                  <a:srgbClr val="34D399"/>
+                </a:solidFill>
+                <a:latin typeface="Calibri"/>
+              </a:rPr>
+              <a:t>"We don't recommend what to learn. We continuously decide what you should learn next."</a:t>
             </a:r>
           </a:p>
         </p:txBody>

</xml_diff>